<commit_message>
feat(pitch-deck): finalize presentation deck, speaker script, and QA deliverables
- embed verified Slide 01 cover image full-bleed
- fix slide 10 to include real demo QR code
- fix slide 12 with explicit https demo URLs
- fix header page numbering format and backup slide marker
- soften slide 06 title to anti-starvation concurrency protection
- add 6m20s conversational speaker-script.md
- add 17-question backup-qa.md and questions-and-answers.md
- validate PPTX (passed schema & relations) and export verified PDF
</commit_message>
<xml_diff>
--- a/docs/presentation/postcode_queue_presentation.pptx
+++ b/docs/presentation/postcode_queue_presentation.pptx
@@ -518,7 +518,7 @@
           <a:p>
             <a:r>
               <a:rPr lang="en-US" dirty="0"/>
-              <a:t>Открываем проблему как маршрут, а не как отдельный талон. За семь минут покажем путь клиента, ядро очереди и границы надёжности.</a:t>
+              <a:t>Добрый день. Мы команда «5 Указателей». Сегодня очередь на почте для клиента начинается только после того, как он уже пришёл в отделение. Мы сделали так, чтобы ещё до выхода из дома он понимал: куда идти и сколько займёт весь визит.</a:t>
             </a:r>
             <a:endParaRPr lang="en-US" dirty="0"/>
           </a:p>
@@ -958,7 +958,7 @@
           <a:p>
             <a:r>
               <a:rPr lang="en-US" dirty="0"/>
-              <a:t>Haversine — оценка расстояния по координатам и ориентиру скорости. Для точного времени в пути нужна дорожная навигация, которой этот контур не обещает.</a:t>
+              <a:t>Haversine — оценка расстояния по координатам и ориентиру скорости. Оценка основана на базовой геометрии; автомобильный трекинг с пробками не заявляется.</a:t>
             </a:r>
             <a:endParaRPr lang="en-US" dirty="0"/>
           </a:p>
@@ -1046,7 +1046,7 @@
           <a:p>
             <a:r>
               <a:rPr lang="en-US" dirty="0"/>
-              <a:t>Единый backend упрощает доменные транзакции очереди и эксплуатацию пилота. Границы модулей оставляют направление для дальнейшего выделения сервисов, но микросервисы не выдаются за текущую архитектуру.</a:t>
+              <a:t>Единый backend упрощает доменные транзакции очереди и эксплуатацию пилота. Границы модулей оставляют направление для дальнейшего выделения сервисов, но распределённые сервисы не заявляются без необходимости.</a:t>
             </a:r>
             <a:endParaRPr lang="en-US" dirty="0"/>
           </a:p>
@@ -1222,7 +1222,7 @@
           <a:p>
             <a:r>
               <a:rPr lang="en-US" dirty="0"/>
-              <a:t>ArgoCD/GitOps даёт воспроизводимое применение манифестов и путь rollback. Масштабирование на 40 000+ отделений — предложение: partitioning и capacity planning должны быть проверены нагрузочными сценариями.</a:t>
+              <a:t>ArgoCD/GitOps даёт воспроизводимое применение манифестов и путь rollback. Масштабирование на 40 000+ отделений — предложение: partitioning и capacity planning требуют отдельного нагрузочного тестирования.</a:t>
             </a:r>
             <a:endParaRPr lang="en-US" dirty="0"/>
           </a:p>
@@ -2278,13 +2278,6 @@
 <file path=ppt/slides/slide1.xml><?xml version="1.0" encoding="utf-8"?>
 <p:sld xmlns:a="http://schemas.openxmlformats.org/drawingml/2006/main" xmlns:r="http://schemas.openxmlformats.org/officeDocument/2006/relationships" xmlns:p="http://schemas.openxmlformats.org/presentationml/2006/main">
   <p:cSld name="Slide 1">
-    <p:bg>
-      <p:bgPr>
-        <a:solidFill>
-          <a:srgbClr val="003B73"/>
-        </a:solidFill>
-      </p:bgPr>
-    </p:bg>
     <p:spTree>
       <p:nvGrpSpPr>
         <p:cNvPr id="1" name=""/>
@@ -2299,183 +2292,30 @@
           <a:chExt cx="0" cy="0"/>
         </a:xfrm>
       </p:grpSpPr>
-      <p:sp>
-        <p:nvSpPr>
-          <p:cNvPr id="2" name="Text 0"/>
-          <p:cNvSpPr/>
-          <p:nvPr/>
-        </p:nvSpPr>
-        <p:spPr>
-          <a:xfrm>
-            <a:off x="914400" y="1371600"/>
-            <a:ext cx="10332720" cy="365760"/>
-          </a:xfrm>
-          <a:prstGeom prst="rect">
-            <a:avLst/>
-          </a:prstGeom>
-          <a:noFill/>
-          <a:ln/>
-        </p:spPr>
-        <p:txBody>
-          <a:bodyPr wrap="square" lIns="0" tIns="0" rIns="0" bIns="0" rtlCol="0" anchor="ctr"/>
-          <a:lstStyle/>
-          <a:p>
-            <a:pPr indent="0" marL="0">
-              <a:buNone/>
-            </a:pPr>
-            <a:r>
-              <a:rPr lang="en-US" sz="1300" b="1" dirty="0">
-                <a:solidFill>
-                  <a:srgbClr val="0EA5E9"/>
-                </a:solidFill>
-                <a:latin typeface="Arial" pitchFamily="34" charset="0"/>
-                <a:ea typeface="Arial" pitchFamily="34" charset="-122"/>
-                <a:cs typeface="Arial" pitchFamily="34" charset="-120"/>
-              </a:rPr>
-              <a:t>POSTCODE CHALLENGE 2026 • ПОЧТА РОССИИ</a:t>
-            </a:r>
-            <a:endParaRPr lang="en-US" sz="1300" dirty="0"/>
-          </a:p>
-        </p:txBody>
-      </p:sp>
-      <p:sp>
-        <p:nvSpPr>
-          <p:cNvPr id="3" name="Text 1"/>
-          <p:cNvSpPr/>
-          <p:nvPr/>
-        </p:nvSpPr>
-        <p:spPr>
-          <a:xfrm>
-            <a:off x="914400" y="1920240"/>
-            <a:ext cx="10332720" cy="1828800"/>
-          </a:xfrm>
-          <a:prstGeom prst="rect">
-            <a:avLst/>
-          </a:prstGeom>
-          <a:noFill/>
-          <a:ln/>
-        </p:spPr>
-        <p:txBody>
-          <a:bodyPr wrap="square" lIns="0" tIns="0" rIns="0" bIns="0" rtlCol="0" anchor="ctr">
-            <a:normAutofit/>
-          </a:bodyPr>
-          <a:lstStyle/>
-          <a:p>
-            <a:pPr indent="0" marL="0">
-              <a:buNone/>
-            </a:pPr>
-            <a:r>
-              <a:rPr lang="en-US" sz="4400" b="1" dirty="0">
-                <a:solidFill>
-                  <a:srgbClr val="FFFFFF"/>
-                </a:solidFill>
-                <a:latin typeface="Arial" pitchFamily="34" charset="0"/>
-                <a:ea typeface="Arial" pitchFamily="34" charset="-122"/>
-                <a:cs typeface="Arial" pitchFamily="34" charset="-120"/>
-              </a:rPr>
-              <a:t>Цифровая очередь</a:t>
-            </a:r>
-            <a:endParaRPr lang="en-US" sz="4400" dirty="0"/>
-          </a:p>
-          <a:p>
-            <a:pPr indent="0" marL="0">
-              <a:buNone/>
-            </a:pPr>
-            <a:r>
-              <a:rPr lang="en-US" sz="4400" b="1" dirty="0">
-                <a:solidFill>
-                  <a:srgbClr val="FFFFFF"/>
-                </a:solidFill>
-                <a:latin typeface="Arial" pitchFamily="34" charset="0"/>
-                <a:ea typeface="Arial" pitchFamily="34" charset="-122"/>
-                <a:cs typeface="Arial" pitchFamily="34" charset="-120"/>
-              </a:rPr>
-              <a:t>нового поколения</a:t>
-            </a:r>
-            <a:endParaRPr lang="en-US" sz="4400" dirty="0"/>
-          </a:p>
-        </p:txBody>
-      </p:sp>
-      <p:sp>
-        <p:nvSpPr>
-          <p:cNvPr id="4" name="Text 2"/>
-          <p:cNvSpPr/>
-          <p:nvPr/>
-        </p:nvSpPr>
-        <p:spPr>
-          <a:xfrm>
-            <a:off x="914400" y="4023360"/>
-            <a:ext cx="9601200" cy="731520"/>
-          </a:xfrm>
-          <a:prstGeom prst="rect">
-            <a:avLst/>
-          </a:prstGeom>
-          <a:noFill/>
-          <a:ln/>
-        </p:spPr>
-        <p:txBody>
-          <a:bodyPr wrap="square" lIns="0" tIns="0" rIns="0" bIns="0" rtlCol="0" anchor="ctr">
-            <a:normAutofit/>
-          </a:bodyPr>
-          <a:lstStyle/>
-          <a:p>
-            <a:pPr indent="0" marL="0">
-              <a:buNone/>
-            </a:pPr>
-            <a:r>
-              <a:rPr lang="en-US" sz="1800" dirty="0">
-                <a:solidFill>
-                  <a:srgbClr val="CADCFC"/>
-                </a:solidFill>
-                <a:latin typeface="Arial" pitchFamily="34" charset="0"/>
-                <a:ea typeface="Arial" pitchFamily="34" charset="-122"/>
-                <a:cs typeface="Arial" pitchFamily="34" charset="-120"/>
-              </a:rPr>
-              <a:t>Маршрут клиента от выбора отделения до подтверждённого визита — с объяснимым CallNext и операционными уведомлениями.</a:t>
-            </a:r>
-            <a:endParaRPr lang="en-US" sz="1800" dirty="0"/>
-          </a:p>
-        </p:txBody>
-      </p:sp>
-      <p:sp>
-        <p:nvSpPr>
-          <p:cNvPr id="5" name="Text 3"/>
-          <p:cNvSpPr/>
-          <p:nvPr/>
-        </p:nvSpPr>
-        <p:spPr>
-          <a:xfrm>
-            <a:off x="914400" y="5669280"/>
-            <a:ext cx="10332720" cy="365760"/>
-          </a:xfrm>
-          <a:prstGeom prst="rect">
-            <a:avLst/>
-          </a:prstGeom>
-          <a:noFill/>
-          <a:ln/>
-        </p:spPr>
-        <p:txBody>
-          <a:bodyPr wrap="square" lIns="0" tIns="0" rIns="0" bIns="0" rtlCol="0" anchor="ctr"/>
-          <a:lstStyle/>
-          <a:p>
-            <a:pPr indent="0" marL="0">
-              <a:buNone/>
-            </a:pPr>
-            <a:r>
-              <a:rPr lang="en-US" sz="1400" dirty="0">
-                <a:solidFill>
-                  <a:srgbClr val="94A3B8"/>
-                </a:solidFill>
-                <a:latin typeface="Arial" pitchFamily="34" charset="0"/>
-                <a:ea typeface="Arial" pitchFamily="34" charset="-122"/>
-                <a:cs typeface="Arial" pitchFamily="34" charset="-120"/>
-              </a:rPr>
-              <a:t>Команда «5 указателей»  |  Go + PostgreSQL + React  |  pointers-team.tech</a:t>
-            </a:r>
-            <a:endParaRPr lang="en-US" sz="1400" dirty="0"/>
-          </a:p>
-        </p:txBody>
-      </p:sp>
+      <p:pic>
+        <p:nvPicPr>
+          <p:cNvPr id="2" name="Image 0" descr="/home/vacuum/Desktop/tsifrovaya-ochered-novogo-pokoleniya/.worktrees/pitch-deck/docs/presentation/assets/slide-01-cover.png">    </p:cNvPr>
+          <p:cNvPicPr>
+            <a:picLocks noChangeAspect="1"/>
+          </p:cNvPicPr>
+          <p:nvPr/>
+        </p:nvPicPr>
+        <p:blipFill>
+          <a:blip r:embed="rId1"/>
+          <a:stretch>
+            <a:fillRect/>
+          </a:stretch>
+        </p:blipFill>
+        <p:spPr>
+          <a:xfrm>
+            <a:off x="0" y="0"/>
+            <a:ext cx="12191695" cy="6858000"/>
+          </a:xfrm>
+          <a:prstGeom prst="rect">
+            <a:avLst/>
+          </a:prstGeom>
+        </p:spPr>
+      </p:pic>
     </p:spTree>
   </p:cSld>
   <p:clrMapOvr>
@@ -2516,7 +2356,7 @@
         </p:nvSpPr>
         <p:spPr>
           <a:xfrm>
-            <a:off x="731520" y="384048"/>
+            <a:off x="731520" y="374904"/>
             <a:ext cx="8046720" cy="228600"/>
           </a:xfrm>
           <a:prstGeom prst="rect">
@@ -2555,8 +2395,8 @@
         </p:nvSpPr>
         <p:spPr>
           <a:xfrm>
-            <a:off x="10561320" y="384048"/>
-            <a:ext cx="868680" cy="228600"/>
+            <a:off x="9875520" y="374904"/>
+            <a:ext cx="1554480" cy="228600"/>
           </a:xfrm>
           <a:prstGeom prst="rect">
             <a:avLst/>
@@ -2580,7 +2420,7 @@
                 <a:ea typeface="Onest" pitchFamily="34" charset="-122"/>
                 <a:cs typeface="Onest" pitchFamily="34" charset="-120"/>
               </a:rPr>
-              <a:t>010 / 12</a:t>
+              <a:t>10 / 12</a:t>
             </a:r>
             <a:endParaRPr lang="en-US" sz="900" dirty="0"/>
           </a:p>
@@ -3434,11 +3274,11 @@
             </a:avLst>
           </a:prstGeom>
           <a:solidFill>
-            <a:srgbClr val="003B73"/>
+            <a:srgbClr val="FFFFFF"/>
           </a:solidFill>
           <a:ln w="12700">
             <a:solidFill>
-              <a:srgbClr val="003B73"/>
+              <a:srgbClr val="D8E3F0"/>
             </a:solidFill>
             <a:prstDash val="solid"/>
           </a:ln>
@@ -3452,8 +3292,8 @@
         </p:nvSpPr>
         <p:spPr>
           <a:xfrm>
-            <a:off x="8961120" y="2240280"/>
-            <a:ext cx="2148840" cy="320040"/>
+            <a:off x="8778240" y="2011680"/>
+            <a:ext cx="2514600" cy="274320"/>
           </a:xfrm>
           <a:prstGeom prst="rect">
             <a:avLst/>
@@ -3469,23 +3309,23 @@
               <a:buNone/>
             </a:pPr>
             <a:r>
-              <a:rPr lang="en-US" sz="2400" b="1" dirty="0">
-                <a:solidFill>
-                  <a:srgbClr val="FFFFFF"/>
-                </a:solidFill>
-                <a:latin typeface="Onest" pitchFamily="34" charset="0"/>
-                <a:ea typeface="Onest" pitchFamily="34" charset="-122"/>
-                <a:cs typeface="Onest" pitchFamily="34" charset="-120"/>
-              </a:rPr>
-              <a:t>DEMO</a:t>
-            </a:r>
-            <a:endParaRPr lang="en-US" sz="2400" dirty="0"/>
+              <a:rPr lang="en-US" sz="1300" b="1" dirty="0">
+                <a:solidFill>
+                  <a:srgbClr val="003B73"/>
+                </a:solidFill>
+                <a:latin typeface="Onest" pitchFamily="34" charset="0"/>
+                <a:ea typeface="Onest" pitchFamily="34" charset="-122"/>
+                <a:cs typeface="Onest" pitchFamily="34" charset="-120"/>
+              </a:rPr>
+              <a:t>ДЕМО-СТЕНД</a:t>
+            </a:r>
+            <a:endParaRPr lang="en-US" sz="1300" dirty="0"/>
           </a:p>
         </p:txBody>
       </p:sp>
       <p:pic>
         <p:nvPicPr>
-          <p:cNvPr id="31" name="Image 0" descr="/home/vacuum/Desktop/tsifrovaya-ochered-novogo-pokoleniya/.worktrees/pitch-deck/docs/presentation/assets/crops/home_smart_route.png">    </p:cNvPr>
+          <p:cNvPr id="31" name="Image 0" descr="/home/vacuum/Desktop/tsifrovaya-ochered-novogo-pokoleniya/.worktrees/pitch-deck/docs/presentation/assets/crops/demo-qr.png">    </p:cNvPr>
           <p:cNvPicPr>
             <a:picLocks noChangeAspect="1"/>
           </p:cNvPicPr>
@@ -3499,8 +3339,8 @@
         </p:blipFill>
         <p:spPr>
           <a:xfrm>
-            <a:off x="9006840" y="2834640"/>
-            <a:ext cx="2057400" cy="1508760"/>
+            <a:off x="9006840" y="2423160"/>
+            <a:ext cx="2057400" cy="2057400"/>
           </a:xfrm>
           <a:prstGeom prst="rect">
             <a:avLst/>
@@ -3515,8 +3355,8 @@
         </p:nvSpPr>
         <p:spPr>
           <a:xfrm>
-            <a:off x="8915400" y="4434840"/>
-            <a:ext cx="2240280" cy="182880"/>
+            <a:off x="8778240" y="4645152"/>
+            <a:ext cx="2514600" cy="228600"/>
           </a:xfrm>
           <a:prstGeom prst="rect">
             <a:avLst/>
@@ -3532,17 +3372,17 @@
               <a:buNone/>
             </a:pPr>
             <a:r>
-              <a:rPr lang="en-US" sz="800" b="1" dirty="0">
-                <a:solidFill>
-                  <a:srgbClr val="CADCFC"/>
-                </a:solidFill>
-                <a:latin typeface="Onest" pitchFamily="34" charset="0"/>
-                <a:ea typeface="Onest" pitchFamily="34" charset="-122"/>
-                <a:cs typeface="Onest" pitchFamily="34" charset="-120"/>
-              </a:rPr>
-              <a:t>DEMO / SMART ROUTE</a:t>
-            </a:r>
-            <a:endParaRPr lang="en-US" sz="800" dirty="0"/>
+              <a:rPr lang="en-US" sz="1000" dirty="0">
+                <a:solidFill>
+                  <a:srgbClr val="64748B"/>
+                </a:solidFill>
+                <a:latin typeface="Onest" pitchFamily="34" charset="0"/>
+                <a:ea typeface="Onest" pitchFamily="34" charset="-122"/>
+                <a:cs typeface="Onest" pitchFamily="34" charset="-120"/>
+              </a:rPr>
+              <a:t>Отсканируйте QR для перехода</a:t>
+            </a:r>
+            <a:endParaRPr lang="en-US" sz="1000" dirty="0"/>
           </a:p>
         </p:txBody>
       </p:sp>
@@ -3554,8 +3394,8 @@
         </p:nvSpPr>
         <p:spPr>
           <a:xfrm>
-            <a:off x="8915400" y="4983480"/>
-            <a:ext cx="2240280" cy="228600"/>
+            <a:off x="8778240" y="5029200"/>
+            <a:ext cx="2514600" cy="274320"/>
           </a:xfrm>
           <a:prstGeom prst="rect">
             <a:avLst/>
@@ -3571,9 +3411,9 @@
               <a:buNone/>
             </a:pPr>
             <a:r>
-              <a:rPr lang="en-US" sz="1100" dirty="0">
-                <a:solidFill>
-                  <a:srgbClr val="CADCFC"/>
+              <a:rPr lang="en-US" sz="1300" b="1" dirty="0">
+                <a:solidFill>
+                  <a:srgbClr val="0E6BD6"/>
                 </a:solidFill>
                 <a:latin typeface="Onest" pitchFamily="34" charset="0"/>
                 <a:ea typeface="Onest" pitchFamily="34" charset="-122"/>
@@ -3581,7 +3421,7 @@
               </a:rPr>
               <a:t>pointers-team.tech</a:t>
             </a:r>
-            <a:endParaRPr lang="en-US" sz="1100" dirty="0"/>
+            <a:endParaRPr lang="en-US" sz="1300" dirty="0"/>
           </a:p>
         </p:txBody>
       </p:sp>
@@ -3703,7 +3543,7 @@
         </p:nvSpPr>
         <p:spPr>
           <a:xfrm>
-            <a:off x="731520" y="384048"/>
+            <a:off x="731520" y="374904"/>
             <a:ext cx="8046720" cy="228600"/>
           </a:xfrm>
           <a:prstGeom prst="rect">
@@ -3742,8 +3582,8 @@
         </p:nvSpPr>
         <p:spPr>
           <a:xfrm>
-            <a:off x="10561320" y="384048"/>
-            <a:ext cx="868680" cy="228600"/>
+            <a:off x="9875520" y="374904"/>
+            <a:ext cx="1554480" cy="228600"/>
           </a:xfrm>
           <a:prstGeom prst="rect">
             <a:avLst/>
@@ -3767,7 +3607,7 @@
                 <a:ea typeface="Onest" pitchFamily="34" charset="-122"/>
                 <a:cs typeface="Onest" pitchFamily="34" charset="-120"/>
               </a:rPr>
-              <a:t>011 / 12</a:t>
+              <a:t>11 / 12</a:t>
             </a:r>
             <a:endParaRPr lang="en-US" sz="900" dirty="0"/>
           </a:p>
@@ -4460,7 +4300,7 @@
         </p:nvSpPr>
         <p:spPr>
           <a:xfrm>
-            <a:off x="731520" y="384048"/>
+            <a:off x="731520" y="374904"/>
             <a:ext cx="8046720" cy="228600"/>
           </a:xfrm>
           <a:prstGeom prst="rect">
@@ -4499,8 +4339,8 @@
         </p:nvSpPr>
         <p:spPr>
           <a:xfrm>
-            <a:off x="10561320" y="384048"/>
-            <a:ext cx="868680" cy="228600"/>
+            <a:off x="9875520" y="374904"/>
+            <a:ext cx="1554480" cy="228600"/>
           </a:xfrm>
           <a:prstGeom prst="rect">
             <a:avLst/>
@@ -4524,7 +4364,7 @@
                 <a:ea typeface="Onest" pitchFamily="34" charset="-122"/>
                 <a:cs typeface="Onest" pitchFamily="34" charset="-120"/>
               </a:rPr>
-              <a:t>012 / 12</a:t>
+              <a:t>12 / 12</a:t>
             </a:r>
             <a:endParaRPr lang="en-US" sz="900" dirty="0"/>
           </a:p>
@@ -4602,7 +4442,7 @@
         </p:nvSpPr>
         <p:spPr>
           <a:xfrm>
-            <a:off x="1051560" y="1965960"/>
+            <a:off x="1051560" y="1874520"/>
             <a:ext cx="9966960" cy="0"/>
           </a:xfrm>
           <a:prstGeom prst="line">
@@ -4627,7 +4467,7 @@
         </p:nvSpPr>
         <p:spPr>
           <a:xfrm>
-            <a:off x="969264" y="1883664"/>
+            <a:off x="969264" y="1792224"/>
             <a:ext cx="164592" cy="164592"/>
           </a:xfrm>
           <a:prstGeom prst="ellipse">
@@ -4652,7 +4492,7 @@
         </p:nvSpPr>
         <p:spPr>
           <a:xfrm>
-            <a:off x="4291584" y="1883664"/>
+            <a:off x="4291584" y="1792224"/>
             <a:ext cx="164592" cy="164592"/>
           </a:xfrm>
           <a:prstGeom prst="ellipse">
@@ -4677,7 +4517,7 @@
         </p:nvSpPr>
         <p:spPr>
           <a:xfrm>
-            <a:off x="7613904" y="1883664"/>
+            <a:off x="7613904" y="1792224"/>
             <a:ext cx="164592" cy="164592"/>
           </a:xfrm>
           <a:prstGeom prst="ellipse">
@@ -4702,7 +4542,7 @@
         </p:nvSpPr>
         <p:spPr>
           <a:xfrm>
-            <a:off x="10936224" y="1883664"/>
+            <a:off x="10936224" y="1792224"/>
             <a:ext cx="164592" cy="164592"/>
           </a:xfrm>
           <a:prstGeom prst="ellipse">
@@ -4727,7 +4567,7 @@
         </p:nvSpPr>
         <p:spPr>
           <a:xfrm>
-            <a:off x="731520" y="2606040"/>
+            <a:off x="731520" y="2423160"/>
             <a:ext cx="3383280" cy="1965960"/>
           </a:xfrm>
           <a:prstGeom prst="roundRect">
@@ -4754,7 +4594,7 @@
         </p:nvSpPr>
         <p:spPr>
           <a:xfrm>
-            <a:off x="1005840" y="2926080"/>
+            <a:off x="1005840" y="2697480"/>
             <a:ext cx="2377440" cy="182880"/>
           </a:xfrm>
           <a:prstGeom prst="rect">
@@ -4793,7 +4633,7 @@
         </p:nvSpPr>
         <p:spPr>
           <a:xfrm>
-            <a:off x="1005840" y="3383280"/>
+            <a:off x="1005840" y="3154680"/>
             <a:ext cx="2834640" cy="685800"/>
           </a:xfrm>
           <a:prstGeom prst="rect">
@@ -4851,7 +4691,7 @@
         </p:nvSpPr>
         <p:spPr>
           <a:xfrm>
-            <a:off x="4389120" y="2606040"/>
+            <a:off x="4389120" y="2423160"/>
             <a:ext cx="3383280" cy="1965960"/>
           </a:xfrm>
           <a:prstGeom prst="roundRect">
@@ -4878,7 +4718,7 @@
         </p:nvSpPr>
         <p:spPr>
           <a:xfrm>
-            <a:off x="4663440" y="2926080"/>
+            <a:off x="4663440" y="2697480"/>
             <a:ext cx="2377440" cy="182880"/>
           </a:xfrm>
           <a:prstGeom prst="rect">
@@ -4917,7 +4757,7 @@
         </p:nvSpPr>
         <p:spPr>
           <a:xfrm>
-            <a:off x="4663440" y="3383280"/>
+            <a:off x="4663440" y="3154680"/>
             <a:ext cx="2834640" cy="685800"/>
           </a:xfrm>
           <a:prstGeom prst="rect">
@@ -4975,7 +4815,7 @@
         </p:nvSpPr>
         <p:spPr>
           <a:xfrm>
-            <a:off x="8046720" y="2606040"/>
+            <a:off x="8046720" y="2423160"/>
             <a:ext cx="3383280" cy="1965960"/>
           </a:xfrm>
           <a:prstGeom prst="roundRect">
@@ -5002,7 +4842,7 @@
         </p:nvSpPr>
         <p:spPr>
           <a:xfrm>
-            <a:off x="8321040" y="2926080"/>
+            <a:off x="8321040" y="2697480"/>
             <a:ext cx="2377440" cy="182880"/>
           </a:xfrm>
           <a:prstGeom prst="rect">
@@ -5041,7 +4881,7 @@
         </p:nvSpPr>
         <p:spPr>
           <a:xfrm>
-            <a:off x="8321040" y="3383280"/>
+            <a:off x="8321040" y="3154680"/>
             <a:ext cx="2834640" cy="685800"/>
           </a:xfrm>
           <a:prstGeom prst="rect">
@@ -5093,30 +4933,96 @@
       </p:sp>
       <p:sp>
         <p:nvSpPr>
-          <p:cNvPr id="20" name="Text 18"/>
-          <p:cNvSpPr/>
-          <p:nvPr/>
-        </p:nvSpPr>
-        <p:spPr>
-          <a:xfrm>
-            <a:off x="914400" y="5349240"/>
-            <a:ext cx="10241280" cy="320040"/>
-          </a:xfrm>
-          <a:prstGeom prst="rect">
-            <a:avLst/>
-          </a:prstGeom>
-          <a:noFill/>
-          <a:ln/>
-        </p:spPr>
-        <p:txBody>
-          <a:bodyPr wrap="square" lIns="0" tIns="0" rIns="0" bIns="0" rtlCol="0" anchor="ctr"/>
-          <a:lstStyle/>
-          <a:p>
-            <a:pPr algn="ctr" indent="0" marL="0">
-              <a:buNone/>
-            </a:pPr>
-            <a:r>
-              <a:rPr lang="en-US" sz="1600" b="1" dirty="0">
+          <p:cNvPr id="20" name="Shape 18"/>
+          <p:cNvSpPr/>
+          <p:nvPr/>
+        </p:nvSpPr>
+        <p:spPr>
+          <a:xfrm>
+            <a:off x="731520" y="4709160"/>
+            <a:ext cx="10698480" cy="1371600"/>
+          </a:xfrm>
+          <a:prstGeom prst="roundRect">
+            <a:avLst>
+              <a:gd name="adj" fmla="val 8000"/>
+            </a:avLst>
+          </a:prstGeom>
+          <a:solidFill>
+            <a:srgbClr val="EAF2FB"/>
+          </a:solidFill>
+          <a:ln w="12700">
+            <a:solidFill>
+              <a:srgbClr val="D8E3F0"/>
+            </a:solidFill>
+            <a:prstDash val="solid"/>
+          </a:ln>
+        </p:spPr>
+      </p:sp>
+      <p:sp>
+        <p:nvSpPr>
+          <p:cNvPr id="21" name="Text 19"/>
+          <p:cNvSpPr/>
+          <p:nvPr/>
+        </p:nvSpPr>
+        <p:spPr>
+          <a:xfrm>
+            <a:off x="1005840" y="4892040"/>
+            <a:ext cx="10149840" cy="201168"/>
+          </a:xfrm>
+          <a:prstGeom prst="rect">
+            <a:avLst/>
+          </a:prstGeom>
+          <a:noFill/>
+          <a:ln/>
+        </p:spPr>
+        <p:txBody>
+          <a:bodyPr wrap="square" lIns="0" tIns="0" rIns="0" bIns="0" rtlCol="0" anchor="ctr"/>
+          <a:lstStyle/>
+          <a:p>
+            <a:pPr indent="0" marL="0">
+              <a:buNone/>
+            </a:pPr>
+            <a:r>
+              <a:rPr lang="en-US" sz="900" b="1" spc="110" kern="0" dirty="0">
+                <a:solidFill>
+                  <a:srgbClr val="0E6BD6"/>
+                </a:solidFill>
+                <a:latin typeface="Onest" pitchFamily="34" charset="0"/>
+                <a:ea typeface="Onest" pitchFamily="34" charset="-122"/>
+                <a:cs typeface="Onest" pitchFamily="34" charset="-120"/>
+              </a:rPr>
+              <a:t>ДЕМОНСТРАЦИОННЫЕ СТЕНДЫ И ПРОВЕРКА РЕШЕНИЯ</a:t>
+            </a:r>
+            <a:endParaRPr lang="en-US" sz="900" dirty="0"/>
+          </a:p>
+        </p:txBody>
+      </p:sp>
+      <p:sp>
+        <p:nvSpPr>
+          <p:cNvPr id="22" name="Text 20"/>
+          <p:cNvSpPr/>
+          <p:nvPr/>
+        </p:nvSpPr>
+        <p:spPr>
+          <a:xfrm>
+            <a:off x="1005840" y="5212080"/>
+            <a:ext cx="10149840" cy="274320"/>
+          </a:xfrm>
+          <a:prstGeom prst="rect">
+            <a:avLst/>
+          </a:prstGeom>
+          <a:noFill/>
+          <a:ln/>
+        </p:spPr>
+        <p:txBody>
+          <a:bodyPr wrap="square" lIns="0" tIns="0" rIns="0" bIns="0" rtlCol="0" anchor="ctr"/>
+          <a:lstStyle/>
+          <a:p>
+            <a:pPr indent="0" marL="0">
+              <a:buNone/>
+            </a:pPr>
+            <a:r>
+              <a:rPr lang="en-US" sz="1300" b="1" dirty="0">
                 <a:solidFill>
                   <a:srgbClr val="003B73"/>
                 </a:solidFill>
@@ -5124,15 +5030,54 @@
                 <a:ea typeface="Onest" pitchFamily="34" charset="-122"/>
                 <a:cs typeface="Onest" pitchFamily="34" charset="-120"/>
               </a:rPr>
-              <a:t>pointers-team.tech  ·  demo  ·  команда «5 указателей»</a:t>
-            </a:r>
-            <a:endParaRPr lang="en-US" sz="1600" dirty="0"/>
-          </a:p>
-        </p:txBody>
-      </p:sp>
-      <p:sp>
-        <p:nvSpPr>
-          <p:cNvPr id="21" name="Text 19"/>
+              <a:t>Основной стенд: https://pointers-team.tech/    ·    Резервный стенд: https://post-queue.duckdns.org/</a:t>
+            </a:r>
+            <a:endParaRPr lang="en-US" sz="1300" dirty="0"/>
+          </a:p>
+        </p:txBody>
+      </p:sp>
+      <p:sp>
+        <p:nvSpPr>
+          <p:cNvPr id="23" name="Text 21"/>
+          <p:cNvSpPr/>
+          <p:nvPr/>
+        </p:nvSpPr>
+        <p:spPr>
+          <a:xfrm>
+            <a:off x="1005840" y="5623560"/>
+            <a:ext cx="10149840" cy="228600"/>
+          </a:xfrm>
+          <a:prstGeom prst="rect">
+            <a:avLst/>
+          </a:prstGeom>
+          <a:noFill/>
+          <a:ln/>
+        </p:spPr>
+        <p:txBody>
+          <a:bodyPr wrap="square" lIns="0" tIns="0" rIns="0" bIns="0" rtlCol="0" anchor="ctr"/>
+          <a:lstStyle/>
+          <a:p>
+            <a:pPr indent="0" marL="0">
+              <a:buNone/>
+            </a:pPr>
+            <a:r>
+              <a:rPr lang="en-US" sz="1100" dirty="0">
+                <a:solidFill>
+                  <a:srgbClr val="64748B"/>
+                </a:solidFill>
+                <a:latin typeface="Onest" pitchFamily="34" charset="0"/>
+                <a:ea typeface="Onest" pitchFamily="34" charset="-122"/>
+                <a:cs typeface="Onest" pitchFamily="34" charset="-120"/>
+              </a:rPr>
+              <a:t>Команда «5 указателей»  ·  Go + PostgreSQL + React  ·  PostCode Challenge 2026</a:t>
+            </a:r>
+            <a:endParaRPr lang="en-US" sz="1100" dirty="0"/>
+          </a:p>
+        </p:txBody>
+      </p:sp>
+      <p:sp>
+        <p:nvSpPr>
+          <p:cNvPr id="24" name="Text 22"/>
           <p:cNvSpPr/>
           <p:nvPr/>
         </p:nvSpPr>
@@ -5171,7 +5116,7 @@
       </p:sp>
       <p:sp>
         <p:nvSpPr>
-          <p:cNvPr id="22" name="Text 20"/>
+          <p:cNvPr id="25" name="Text 23"/>
           <p:cNvSpPr/>
           <p:nvPr/>
         </p:nvSpPr>
@@ -5248,7 +5193,7 @@
         </p:nvSpPr>
         <p:spPr>
           <a:xfrm>
-            <a:off x="731520" y="384048"/>
+            <a:off x="731520" y="374904"/>
             <a:ext cx="8046720" cy="228600"/>
           </a:xfrm>
           <a:prstGeom prst="rect">
@@ -5287,8 +5232,8 @@
         </p:nvSpPr>
         <p:spPr>
           <a:xfrm>
-            <a:off x="10561320" y="384048"/>
-            <a:ext cx="868680" cy="228600"/>
+            <a:off x="9875520" y="374904"/>
+            <a:ext cx="1554480" cy="228600"/>
           </a:xfrm>
           <a:prstGeom prst="rect">
             <a:avLst/>
@@ -5312,7 +5257,7 @@
                 <a:ea typeface="Onest" pitchFamily="34" charset="-122"/>
                 <a:cs typeface="Onest" pitchFamily="34" charset="-120"/>
               </a:rPr>
-              <a:t>0B / 12</a:t>
+              <a:t>BACKUP</a:t>
             </a:r>
             <a:endParaRPr lang="en-US" sz="900" dirty="0"/>
           </a:p>
@@ -5707,7 +5652,7 @@
         </p:nvSpPr>
         <p:spPr>
           <a:xfrm>
-            <a:off x="731520" y="384048"/>
+            <a:off x="731520" y="374904"/>
             <a:ext cx="8046720" cy="228600"/>
           </a:xfrm>
           <a:prstGeom prst="rect">
@@ -5746,8 +5691,8 @@
         </p:nvSpPr>
         <p:spPr>
           <a:xfrm>
-            <a:off x="10561320" y="384048"/>
-            <a:ext cx="868680" cy="228600"/>
+            <a:off x="9875520" y="374904"/>
+            <a:ext cx="1554480" cy="228600"/>
           </a:xfrm>
           <a:prstGeom prst="rect">
             <a:avLst/>
@@ -5771,7 +5716,7 @@
                 <a:ea typeface="Onest" pitchFamily="34" charset="-122"/>
                 <a:cs typeface="Onest" pitchFamily="34" charset="-120"/>
               </a:rPr>
-              <a:t>0B / 12</a:t>
+              <a:t>BACKUP</a:t>
             </a:r>
             <a:endParaRPr lang="en-US" sz="900" dirty="0"/>
           </a:p>
@@ -6032,7 +5977,7 @@
                 <a:ea typeface="Onest" pitchFamily="34" charset="-122"/>
                 <a:cs typeface="Onest" pitchFamily="34" charset="-120"/>
               </a:rPr>
-              <a:t>Ориентир выбора отделения, не дорожная навигация.</a:t>
+              <a:t>Ориентир выбора отделения, а не автомобильный трекинг с пробками.</a:t>
             </a:r>
             <a:endParaRPr lang="en-US" sz="1500" dirty="0"/>
           </a:p>
@@ -6117,7 +6062,7 @@
         </p:nvSpPr>
         <p:spPr>
           <a:xfrm>
-            <a:off x="731520" y="384048"/>
+            <a:off x="731520" y="374904"/>
             <a:ext cx="8046720" cy="228600"/>
           </a:xfrm>
           <a:prstGeom prst="rect">
@@ -6156,8 +6101,8 @@
         </p:nvSpPr>
         <p:spPr>
           <a:xfrm>
-            <a:off x="10561320" y="384048"/>
-            <a:ext cx="868680" cy="228600"/>
+            <a:off x="9875520" y="374904"/>
+            <a:ext cx="1554480" cy="228600"/>
           </a:xfrm>
           <a:prstGeom prst="rect">
             <a:avLst/>
@@ -6181,7 +6126,7 @@
                 <a:ea typeface="Onest" pitchFamily="34" charset="-122"/>
                 <a:cs typeface="Onest" pitchFamily="34" charset="-120"/>
               </a:rPr>
-              <a:t>0B / 12</a:t>
+              <a:t>BACKUP</a:t>
             </a:r>
             <a:endParaRPr lang="en-US" sz="900" dirty="0"/>
           </a:p>
@@ -6608,7 +6553,7 @@
         </p:nvSpPr>
         <p:spPr>
           <a:xfrm>
-            <a:off x="731520" y="384048"/>
+            <a:off x="731520" y="374904"/>
             <a:ext cx="8046720" cy="228600"/>
           </a:xfrm>
           <a:prstGeom prst="rect">
@@ -6647,8 +6592,8 @@
         </p:nvSpPr>
         <p:spPr>
           <a:xfrm>
-            <a:off x="10561320" y="384048"/>
-            <a:ext cx="868680" cy="228600"/>
+            <a:off x="9875520" y="374904"/>
+            <a:ext cx="1554480" cy="228600"/>
           </a:xfrm>
           <a:prstGeom prst="rect">
             <a:avLst/>
@@ -6672,7 +6617,7 @@
                 <a:ea typeface="Onest" pitchFamily="34" charset="-122"/>
                 <a:cs typeface="Onest" pitchFamily="34" charset="-120"/>
               </a:rPr>
-              <a:t>0B / 12</a:t>
+              <a:t>BACKUP</a:t>
             </a:r>
             <a:endParaRPr lang="en-US" sz="900" dirty="0"/>
           </a:p>
@@ -7170,7 +7115,7 @@
         </p:nvSpPr>
         <p:spPr>
           <a:xfrm>
-            <a:off x="731520" y="384048"/>
+            <a:off x="731520" y="374904"/>
             <a:ext cx="8046720" cy="228600"/>
           </a:xfrm>
           <a:prstGeom prst="rect">
@@ -7209,8 +7154,8 @@
         </p:nvSpPr>
         <p:spPr>
           <a:xfrm>
-            <a:off x="10561320" y="384048"/>
-            <a:ext cx="868680" cy="228600"/>
+            <a:off x="9875520" y="374904"/>
+            <a:ext cx="1554480" cy="228600"/>
           </a:xfrm>
           <a:prstGeom prst="rect">
             <a:avLst/>
@@ -7234,7 +7179,7 @@
                 <a:ea typeface="Onest" pitchFamily="34" charset="-122"/>
                 <a:cs typeface="Onest" pitchFamily="34" charset="-120"/>
               </a:rPr>
-              <a:t>0B / 12</a:t>
+              <a:t>BACKUP</a:t>
             </a:r>
             <a:endParaRPr lang="en-US" sz="900" dirty="0"/>
           </a:p>
@@ -7629,7 +7574,7 @@
         </p:nvSpPr>
         <p:spPr>
           <a:xfrm>
-            <a:off x="731520" y="384048"/>
+            <a:off x="731520" y="374904"/>
             <a:ext cx="8046720" cy="228600"/>
           </a:xfrm>
           <a:prstGeom prst="rect">
@@ -7668,8 +7613,8 @@
         </p:nvSpPr>
         <p:spPr>
           <a:xfrm>
-            <a:off x="10561320" y="384048"/>
-            <a:ext cx="868680" cy="228600"/>
+            <a:off x="9875520" y="374904"/>
+            <a:ext cx="1554480" cy="228600"/>
           </a:xfrm>
           <a:prstGeom prst="rect">
             <a:avLst/>
@@ -8483,7 +8428,7 @@
         </p:nvSpPr>
         <p:spPr>
           <a:xfrm>
-            <a:off x="731520" y="384048"/>
+            <a:off x="731520" y="374904"/>
             <a:ext cx="8046720" cy="228600"/>
           </a:xfrm>
           <a:prstGeom prst="rect">
@@ -8522,8 +8467,8 @@
         </p:nvSpPr>
         <p:spPr>
           <a:xfrm>
-            <a:off x="10561320" y="384048"/>
-            <a:ext cx="868680" cy="228600"/>
+            <a:off x="9875520" y="374904"/>
+            <a:ext cx="1554480" cy="228600"/>
           </a:xfrm>
           <a:prstGeom prst="rect">
             <a:avLst/>
@@ -9189,7 +9134,7 @@
         </p:nvSpPr>
         <p:spPr>
           <a:xfrm>
-            <a:off x="731520" y="384048"/>
+            <a:off x="731520" y="374904"/>
             <a:ext cx="8046720" cy="228600"/>
           </a:xfrm>
           <a:prstGeom prst="rect">
@@ -9228,8 +9173,8 @@
         </p:nvSpPr>
         <p:spPr>
           <a:xfrm>
-            <a:off x="10561320" y="384048"/>
-            <a:ext cx="868680" cy="228600"/>
+            <a:off x="9875520" y="374904"/>
+            <a:ext cx="1554480" cy="228600"/>
           </a:xfrm>
           <a:prstGeom prst="rect">
             <a:avLst/>
@@ -9930,7 +9875,7 @@
         </p:nvSpPr>
         <p:spPr>
           <a:xfrm>
-            <a:off x="731520" y="384048"/>
+            <a:off x="731520" y="374904"/>
             <a:ext cx="8046720" cy="228600"/>
           </a:xfrm>
           <a:prstGeom prst="rect">
@@ -9969,8 +9914,8 @@
         </p:nvSpPr>
         <p:spPr>
           <a:xfrm>
-            <a:off x="10561320" y="384048"/>
-            <a:ext cx="868680" cy="228600"/>
+            <a:off x="9875520" y="374904"/>
+            <a:ext cx="1554480" cy="228600"/>
           </a:xfrm>
           <a:prstGeom prst="rect">
             <a:avLst/>
@@ -10739,7 +10684,7 @@
         </p:nvSpPr>
         <p:spPr>
           <a:xfrm>
-            <a:off x="731520" y="384048"/>
+            <a:off x="731520" y="374904"/>
             <a:ext cx="8046720" cy="228600"/>
           </a:xfrm>
           <a:prstGeom prst="rect">
@@ -10778,8 +10723,8 @@
         </p:nvSpPr>
         <p:spPr>
           <a:xfrm>
-            <a:off x="10561320" y="384048"/>
-            <a:ext cx="868680" cy="228600"/>
+            <a:off x="9875520" y="374904"/>
+            <a:ext cx="1554480" cy="228600"/>
           </a:xfrm>
           <a:prstGeom prst="rect">
             <a:avLst/>
@@ -10867,7 +10812,7 @@
                 <a:ea typeface="Onest" pitchFamily="34" charset="-122"/>
                 <a:cs typeface="Onest" pitchFamily="34" charset="-120"/>
               </a:rPr>
-              <a:t>Очередь не голодает и не блокирует окно</a:t>
+              <a:t>Anti-starvation и защита от блокировок при конкурентном вызове</a:t>
             </a:r>
             <a:endParaRPr lang="en-US" sz="2500" dirty="0"/>
           </a:p>
@@ -11548,7 +11493,7 @@
         </p:nvSpPr>
         <p:spPr>
           <a:xfrm>
-            <a:off x="731520" y="384048"/>
+            <a:off x="731520" y="374904"/>
             <a:ext cx="8046720" cy="228600"/>
           </a:xfrm>
           <a:prstGeom prst="rect">
@@ -11587,8 +11532,8 @@
         </p:nvSpPr>
         <p:spPr>
           <a:xfrm>
-            <a:off x="10561320" y="384048"/>
-            <a:ext cx="868680" cy="228600"/>
+            <a:off x="9875520" y="374904"/>
+            <a:ext cx="1554480" cy="228600"/>
           </a:xfrm>
           <a:prstGeom prst="rect">
             <a:avLst/>
@@ -12070,7 +12015,7 @@
         </p:nvSpPr>
         <p:spPr>
           <a:xfrm>
-            <a:off x="731520" y="384048"/>
+            <a:off x="731520" y="374904"/>
             <a:ext cx="8046720" cy="228600"/>
           </a:xfrm>
           <a:prstGeom prst="rect">
@@ -12109,8 +12054,8 @@
         </p:nvSpPr>
         <p:spPr>
           <a:xfrm>
-            <a:off x="10561320" y="384048"/>
-            <a:ext cx="868680" cy="228600"/>
+            <a:off x="9875520" y="374904"/>
+            <a:ext cx="1554480" cy="228600"/>
           </a:xfrm>
           <a:prstGeom prst="rect">
             <a:avLst/>
@@ -12880,7 +12825,7 @@
         </p:nvSpPr>
         <p:spPr>
           <a:xfrm>
-            <a:off x="731520" y="384048"/>
+            <a:off x="731520" y="374904"/>
             <a:ext cx="8046720" cy="228600"/>
           </a:xfrm>
           <a:prstGeom prst="rect">
@@ -12919,8 +12864,8 @@
         </p:nvSpPr>
         <p:spPr>
           <a:xfrm>
-            <a:off x="10561320" y="384048"/>
-            <a:ext cx="868680" cy="228600"/>
+            <a:off x="9875520" y="374904"/>
+            <a:ext cx="1554480" cy="228600"/>
           </a:xfrm>
           <a:prstGeom prst="rect">
             <a:avLst/>

</xml_diff>